<commit_message>
Correct 1 Timothy 4:7 to "old wives' tales" (NIV)
Co-Authored-By: Claude Opus 5.5 <noreply@anthropic.com>
Claude-Session: https://claude.ai/code/session_01MuymF1m7EVQavCwKrD3GwF
</commit_message>
<xml_diff>
--- a/presentation/Sower-of-Best.pptx
+++ b/presentation/Sower-of-Best.pptx
@@ -135,7 +135,7 @@
   <p:extLst>
     <p:ext uri="{521415D9-36F7-43E2-AB2F-B90AF26B5E84}">
       <p14:sectionLst xmlns:p14="http://schemas.microsoft.com/office/powerpoint/2010/main">
-        <p14:section name="Introduction" id="{2cc70a21-d150-0058-ec8f-147912ac48eb}">
+        <p14:section name="Introduction" id="{07ddbb98-2b12-6bd0-a6f9-157e10e731da}">
           <p14:sldIdLst>
             <p14:sldId id="256"/>
             <p14:sldId id="257"/>
@@ -144,7 +144,7 @@
             <p14:sldId id="260"/>
           </p14:sldIdLst>
         </p14:section>
-        <p14:section name="1. Sow Positive Attitudes" id="{9fcb58df-817a-e849-9029-378384b56c18}">
+        <p14:section name="1. Sow Positive Attitudes" id="{794cf7d0-253e-e27f-99ba-4ec8720f0863}">
           <p14:sldIdLst>
             <p14:sldId id="261"/>
             <p14:sldId id="262"/>
@@ -152,7 +152,7 @@
             <p14:sldId id="264"/>
           </p14:sldIdLst>
         </p14:section>
-        <p14:section name="2. Sow Integrity" id="{29c41558-4ff4-d3d2-44aa-b43577658a72}">
+        <p14:section name="2. Sow Integrity" id="{f5d7f4f6-3e7a-af4d-2f5a-44e8d218c040}">
           <p14:sldIdLst>
             <p14:sldId id="265"/>
             <p14:sldId id="266"/>
@@ -160,7 +160,7 @@
             <p14:sldId id="268"/>
           </p14:sldIdLst>
         </p14:section>
-        <p14:section name="3. Sow Spirituality" id="{56781cb6-6e52-afc5-4b79-87930a5256b8}">
+        <p14:section name="3. Sow Spirituality" id="{864511ac-76de-a3d7-2922-b35347cde148}">
           <p14:sldIdLst>
             <p14:sldId id="269"/>
             <p14:sldId id="270"/>
@@ -168,7 +168,7 @@
             <p14:sldId id="272"/>
           </p14:sldIdLst>
         </p14:section>
-        <p14:section name="4. Sow Discipline" id="{1d8db1f8-3a15-c273-3dee-90525a914bd9}">
+        <p14:section name="4. Sow Discipline" id="{70684ab3-a1ff-c798-0ff0-34a08751ee27}">
           <p14:sldIdLst>
             <p14:sldId id="273"/>
             <p14:sldId id="274"/>
@@ -177,7 +177,7 @@
             <p14:sldId id="277"/>
           </p14:sldIdLst>
         </p14:section>
-        <p14:section name="5. Sow A Correct Image" id="{98ad9486-710e-26b8-2b60-7c66a41a2f9e}">
+        <p14:section name="5. Sow A Correct Image" id="{8ff3b32c-3912-6225-1989-afcb4bbe2be9}">
           <p14:sldIdLst>
             <p14:sldId id="278"/>
             <p14:sldId id="279"/>
@@ -187,7 +187,7 @@
             <p14:sldId id="283"/>
           </p14:sldIdLst>
         </p14:section>
-        <p14:section name="Summary" id="{4999a83a-1b37-3927-bf44-075bf3664866}">
+        <p14:section name="Summary" id="{86820662-5ed7-8096-b919-61b799855c8a}">
           <p14:sldIdLst>
             <p14:sldId id="284"/>
           </p14:sldIdLst>
@@ -773,7 +773,7 @@
           <a:p>
             <a:r>
               <a:rPr lang="en-US" dirty="0"/>
-              <a:t>1 Timothy 4:7–8 (NIV) Have nothing to do with godless myths and old lives' tales; rather, train yourself to be godly.  For physical training is of some value, but godliness has value for all things, holding promise for both the present life and the life to come.</a:t>
+              <a:t>1 Timothy 4:7–8 (NIV) Have nothing to do with godless myths and old wives' tales; rather, train yourself to be godly.  For physical training is of some value, but godliness has value for all things, holding promise for both the present life and the life to come.</a:t>
             </a:r>
             <a:endParaRPr lang="en-US" dirty="0"/>
           </a:p>
@@ -4858,7 +4858,7 @@
                 <a:ea typeface="Cambria" pitchFamily="34" charset="-122"/>
                 <a:cs typeface="Cambria" pitchFamily="34" charset="-120"/>
               </a:rPr>
-              <a:t>Have nothing to do with godless myths and old lives' tales; rather, </a:t>
+              <a:t>Have nothing to do with godless myths and old wives' tales; rather, </a:t>
             </a:r>
             <a:pPr indent="0" marL="0">
               <a:lnSpc>

</xml_diff>